<commit_message>
docs: add deployment notes for Hostinger (auto-deploy from GitHub)
</commit_message>
<xml_diff>
--- a/equiprent-enterprise/excel/Proposal EquipRent Enterprise.pptx
+++ b/equiprent-enterprise/excel/Proposal EquipRent Enterprise.pptx
@@ -2557,70 +2557,6 @@
           </a:p>
         </p:txBody>
       </p:sp>
-      <p:sp>
-        <p:nvSpPr>
-          <p:cNvPr id="11" name="Text 9"/>
-          <p:cNvSpPr/>
-          <p:nvPr/>
-        </p:nvSpPr>
-        <p:spPr>
-          <a:xfrm>
-            <a:off x="8509000" y="2667000"/>
-            <a:ext cx="3139440" cy="695854"/>
-          </a:xfrm>
-          <a:prstGeom prst="rect">
-            <a:avLst/>
-          </a:prstGeom>
-          <a:noFill/>
-          <a:ln/>
-        </p:spPr>
-        <p:txBody>
-          <a:bodyPr wrap="square" lIns="0" tIns="0" rIns="0" bIns="0" rtlCol="0" anchor="t">
-            <a:normAutofit/>
-          </a:bodyPr>
-          <a:lstStyle/>
-          <a:p>
-            <a:pPr marL="0" indent="0" algn="l">
-              <a:lnSpc>
-                <a:spcPts val="2640"/>
-              </a:lnSpc>
-              <a:buNone/>
-            </a:pPr>
-            <a:r>
-              <a:rPr lang="en-US" sz="2200" b="1" dirty="0">
-                <a:solidFill>
-                  <a:srgbClr val="F5F7FB"/>
-                </a:solidFill>
-                <a:latin typeface="Plus Jakarta Sans" pitchFamily="34" charset="0"/>
-                <a:ea typeface="Plus Jakarta Sans" pitchFamily="34" charset="-122"/>
-                <a:cs typeface="Plus Jakarta Sans" pitchFamily="34" charset="-120"/>
-              </a:rPr>
-              <a:t>Rp100.000.000</a:t>
-            </a:r>
-            <a:endParaRPr lang="en-US" sz="2200" dirty="0"/>
-          </a:p>
-          <a:p>
-            <a:pPr marL="0" indent="0" algn="l">
-              <a:lnSpc>
-                <a:spcPts val="2640"/>
-              </a:lnSpc>
-              <a:buNone/>
-            </a:pPr>
-            <a:r>
-              <a:rPr lang="en-US" sz="2200" b="1" dirty="0">
-                <a:solidFill>
-                  <a:srgbClr val="BFD3FB"/>
-                </a:solidFill>
-                <a:latin typeface="Plus Jakarta Sans" pitchFamily="34" charset="0"/>
-                <a:ea typeface="Plus Jakarta Sans" pitchFamily="34" charset="-122"/>
-                <a:cs typeface="Plus Jakarta Sans" pitchFamily="34" charset="-120"/>
-              </a:rPr>
-              <a:t>fixed price · all-in</a:t>
-            </a:r>
-            <a:endParaRPr lang="en-US" sz="2200" dirty="0"/>
-          </a:p>
-        </p:txBody>
-      </p:sp>
     </p:spTree>
   </p:cSld>
   <p:clrMapOvr>
@@ -2762,7 +2698,7 @@
         </p:nvGraphicFramePr>
         <p:xfrm>
           <a:off x="824089" y="1873513"/>
-          <a:ext cx="10555111" cy="2840567"/>
+          <a:ext cx="10555111" cy="2646053"/>
         </p:xfrm>
         <a:graphic>
           <a:graphicData uri="http://schemas.openxmlformats.org/drawingml/2006/table">
@@ -4582,7 +4518,7 @@
         </p:spPr>
         <p:txBody>
           <a:bodyPr wrap="square" lIns="0" tIns="0" rIns="0" bIns="0" rtlCol="0" anchor="t">
-            <a:normAutofit/>
+            <a:normAutofit fontScale="32500" lnSpcReduction="20000"/>
           </a:bodyPr>
           <a:lstStyle/>
           <a:p>
@@ -4623,7 +4559,7 @@
         </p:nvGraphicFramePr>
         <p:xfrm>
           <a:off x="4329289" y="824089"/>
-          <a:ext cx="7049911" cy="4636382"/>
+          <a:ext cx="7049911" cy="4636380"/>
         </p:xfrm>
         <a:graphic>
           <a:graphicData uri="http://schemas.openxmlformats.org/drawingml/2006/table">
@@ -7805,171 +7741,6 @@
       </p:sp>
       <p:sp>
         <p:nvSpPr>
-          <p:cNvPr id="6" name="Text 4"/>
-          <p:cNvSpPr/>
-          <p:nvPr/>
-        </p:nvSpPr>
-        <p:spPr>
-          <a:xfrm>
-            <a:off x="1170488" y="2523158"/>
-            <a:ext cx="4722678" cy="1461558"/>
-          </a:xfrm>
-          <a:prstGeom prst="rect">
-            <a:avLst/>
-          </a:prstGeom>
-          <a:noFill/>
-          <a:ln/>
-        </p:spPr>
-        <p:txBody>
-          <a:bodyPr wrap="square" lIns="0" tIns="0" rIns="0" bIns="0" rtlCol="0" anchor="t">
-            <a:normAutofit/>
-          </a:bodyPr>
-          <a:lstStyle/>
-          <a:p>
-            <a:pPr marL="155956" indent="-155956" algn="l">
-              <a:lnSpc>
-                <a:spcPts val="1885"/>
-              </a:lnSpc>
-              <a:buSzPct val="100000"/>
-              <a:buChar char="•"/>
-            </a:pPr>
-            <a:r>
-              <a:rPr lang="en-US" sz="1300">
-                <a:solidFill>
-                  <a:srgbClr val="4A5670"/>
-                </a:solidFill>
-                <a:latin typeface="Inter" pitchFamily="34" charset="0"/>
-                <a:ea typeface="Inter" pitchFamily="34" charset="-122"/>
-                <a:cs typeface="Inter" pitchFamily="34" charset="-120"/>
-              </a:rPr>
-              <a:t>Semua modul di proposal ini</a:t>
-            </a:r>
-          </a:p>
-          <a:p>
-            <a:pPr marL="155956" indent="-155956" algn="l">
-              <a:lnSpc>
-                <a:spcPts val="1885"/>
-              </a:lnSpc>
-              <a:buSzPct val="100000"/>
-              <a:buChar char="•"/>
-            </a:pPr>
-            <a:r>
-              <a:rPr lang="en-US" sz="1300">
-                <a:solidFill>
-                  <a:srgbClr val="4A5670"/>
-                </a:solidFill>
-                <a:latin typeface="Inter" pitchFamily="34" charset="0"/>
-                <a:ea typeface="Inter" pitchFamily="34" charset="-122"/>
-                <a:cs typeface="Inter" pitchFamily="34" charset="-120"/>
-              </a:rPr>
-              <a:t>Hosting, domain &amp; SSL tahun pertama</a:t>
-            </a:r>
-          </a:p>
-          <a:p>
-            <a:pPr marL="155956" indent="-155956" algn="l">
-              <a:lnSpc>
-                <a:spcPts val="1885"/>
-              </a:lnSpc>
-              <a:buSzPct val="100000"/>
-              <a:buChar char="•"/>
-            </a:pPr>
-            <a:r>
-              <a:rPr lang="en-US" sz="1300">
-                <a:solidFill>
-                  <a:srgbClr val="4A5670"/>
-                </a:solidFill>
-                <a:latin typeface="Inter" pitchFamily="34" charset="0"/>
-                <a:ea typeface="Inter" pitchFamily="34" charset="-122"/>
-                <a:cs typeface="Inter" pitchFamily="34" charset="-120"/>
-              </a:rPr>
-              <a:t>Maintenance web server &amp; backup database mingguan tahun pertama</a:t>
-            </a:r>
-          </a:p>
-          <a:p>
-            <a:pPr marL="155956" indent="-155956" algn="l">
-              <a:lnSpc>
-                <a:spcPts val="1885"/>
-              </a:lnSpc>
-              <a:buSzPct val="100000"/>
-              <a:buChar char="•"/>
-            </a:pPr>
-            <a:r>
-              <a:rPr lang="en-US" sz="1300">
-                <a:solidFill>
-                  <a:srgbClr val="4A5670"/>
-                </a:solidFill>
-                <a:latin typeface="Inter" pitchFamily="34" charset="0"/>
-                <a:ea typeface="Inter" pitchFamily="34" charset="-122"/>
-                <a:cs typeface="Inter" pitchFamily="34" charset="-120"/>
-              </a:rPr>
-              <a:t>Migrasi data dari Excel / sistem lama</a:t>
-            </a:r>
-          </a:p>
-          <a:p>
-            <a:pPr marL="155956" indent="-155956" algn="l">
-              <a:lnSpc>
-                <a:spcPts val="1885"/>
-              </a:lnSpc>
-              <a:buSzPct val="100000"/>
-              <a:buChar char="•"/>
-            </a:pPr>
-            <a:r>
-              <a:rPr lang="en-US" sz="1300">
-                <a:solidFill>
-                  <a:srgbClr val="4A5670"/>
-                </a:solidFill>
-                <a:latin typeface="Inter" pitchFamily="34" charset="0"/>
-                <a:ea typeface="Inter" pitchFamily="34" charset="-122"/>
-                <a:cs typeface="Inter" pitchFamily="34" charset="-120"/>
-              </a:rPr>
-              <a:t>Pelatihan per peran &amp; panduan pengguna</a:t>
-            </a:r>
-          </a:p>
-          <a:p>
-            <a:pPr marL="155956" indent="-155956" algn="l">
-              <a:lnSpc>
-                <a:spcPts val="1885"/>
-              </a:lnSpc>
-              <a:buSzPct val="100000"/>
-              <a:buChar char="•"/>
-            </a:pPr>
-            <a:r>
-              <a:rPr lang="en-US" sz="1300">
-                <a:solidFill>
-                  <a:srgbClr val="4A5670"/>
-                </a:solidFill>
-                <a:latin typeface="Inter" pitchFamily="34" charset="0"/>
-                <a:ea typeface="Inter" pitchFamily="34" charset="-122"/>
-                <a:cs typeface="Inter" pitchFamily="34" charset="-120"/>
-              </a:rPr>
-              <a:t>Testing, go-live &amp; maintenance 4 bulan</a:t>
-            </a:r>
-          </a:p>
-          <a:p>
-            <a:pPr marL="155956" indent="-155956" algn="l">
-              <a:lnSpc>
-                <a:spcPts val="1885"/>
-              </a:lnSpc>
-              <a:buSzPct val="100000"/>
-              <a:buChar char="•"/>
-            </a:pPr>
-            <a:r>
-              <a:rPr lang="en-US" sz="1300">
-                <a:solidFill>
-                  <a:srgbClr val="4A5670"/>
-                </a:solidFill>
-                <a:latin typeface="Inter" pitchFamily="34" charset="0"/>
-                <a:ea typeface="Inter" pitchFamily="34" charset="-122"/>
-                <a:cs typeface="Inter" pitchFamily="34" charset="-120"/>
-              </a:rPr>
-              <a:t>Perbaikan bug tanpa biaya selama masa maintenance</a:t>
-            </a:r>
-            <a:endParaRPr lang="en-US" sz="1300" dirty="0"/>
-          </a:p>
-        </p:txBody>
-      </p:sp>
-      <p:sp>
-        <p:nvSpPr>
           <p:cNvPr id="7" name="Shape 5"/>
           <p:cNvSpPr/>
           <p:nvPr/>
@@ -8161,7 +7932,7 @@
               <a:buChar char="•"/>
             </a:pPr>
             <a:r>
-              <a:rPr lang="en-US" sz="1300">
+              <a:rPr lang="en-US" sz="1300" dirty="0">
                 <a:solidFill>
                   <a:srgbClr val="4A5670"/>
                 </a:solidFill>
@@ -8169,7 +7940,62 @@
                 <a:ea typeface="Inter" pitchFamily="34" charset="-122"/>
                 <a:cs typeface="Inter" pitchFamily="34" charset="-120"/>
               </a:rPr>
-              <a:t>Hosting &amp; maintenance mulai tahun kedua</a:t>
+              <a:t>Hosting &amp; maintenance </a:t>
+            </a:r>
+            <a:r>
+              <a:rPr lang="en-US" sz="1300" dirty="0" err="1">
+                <a:solidFill>
+                  <a:srgbClr val="4A5670"/>
+                </a:solidFill>
+                <a:latin typeface="Inter" pitchFamily="34" charset="0"/>
+                <a:ea typeface="Inter" pitchFamily="34" charset="-122"/>
+                <a:cs typeface="Inter" pitchFamily="34" charset="-120"/>
+              </a:rPr>
+              <a:t>mulai</a:t>
+            </a:r>
+            <a:r>
+              <a:rPr lang="en-US" sz="1300" dirty="0">
+                <a:solidFill>
+                  <a:srgbClr val="4A5670"/>
+                </a:solidFill>
+                <a:latin typeface="Inter" pitchFamily="34" charset="0"/>
+                <a:ea typeface="Inter" pitchFamily="34" charset="-122"/>
+                <a:cs typeface="Inter" pitchFamily="34" charset="-120"/>
+              </a:rPr>
+              <a:t> </a:t>
+            </a:r>
+            <a:r>
+              <a:rPr lang="en-US" sz="1300" dirty="0" err="1">
+                <a:solidFill>
+                  <a:srgbClr val="4A5670"/>
+                </a:solidFill>
+                <a:latin typeface="Inter" pitchFamily="34" charset="0"/>
+                <a:ea typeface="Inter" pitchFamily="34" charset="-122"/>
+                <a:cs typeface="Inter" pitchFamily="34" charset="-120"/>
+              </a:rPr>
+              <a:t>tahun</a:t>
+            </a:r>
+            <a:r>
+              <a:rPr lang="en-US" sz="1300" dirty="0">
+                <a:solidFill>
+                  <a:srgbClr val="4A5670"/>
+                </a:solidFill>
+                <a:latin typeface="Inter" pitchFamily="34" charset="0"/>
+                <a:ea typeface="Inter" pitchFamily="34" charset="-122"/>
+                <a:cs typeface="Inter" pitchFamily="34" charset="-120"/>
+              </a:rPr>
+              <a:t> </a:t>
+            </a:r>
+            <a:r>
+              <a:rPr lang="en-US" sz="1300" dirty="0" err="1">
+                <a:solidFill>
+                  <a:srgbClr val="4A5670"/>
+                </a:solidFill>
+                <a:latin typeface="Inter" pitchFamily="34" charset="0"/>
+                <a:ea typeface="Inter" pitchFamily="34" charset="-122"/>
+                <a:cs typeface="Inter" pitchFamily="34" charset="-120"/>
+              </a:rPr>
+              <a:t>kedua</a:t>
             </a:r>
             <a:endParaRPr lang="en-US" sz="1300" dirty="0"/>
           </a:p>
@@ -8216,6 +8042,253 @@
               <a:t>EquipRent Enterprise · Proposal 2026 · 13</a:t>
             </a:r>
             <a:endParaRPr lang="en-US" sz="1200" dirty="0"/>
+          </a:p>
+        </p:txBody>
+      </p:sp>
+      <p:sp>
+        <p:nvSpPr>
+          <p:cNvPr id="12" name="Text 7">
+            <a:extLst>
+              <a:ext uri="{FF2B5EF4-FFF2-40B4-BE49-F238E27FC236}">
+                <a16:creationId xmlns:a16="http://schemas.microsoft.com/office/drawing/2014/main" id="{5246F0B6-065D-119A-75B5-81D1F08FC10E}"/>
+              </a:ext>
+            </a:extLst>
+          </p:cNvPr>
+          <p:cNvSpPr/>
+          <p:nvPr/>
+        </p:nvSpPr>
+        <p:spPr>
+          <a:xfrm>
+            <a:off x="1178108" y="2523157"/>
+            <a:ext cx="4722678" cy="1779336"/>
+          </a:xfrm>
+          <a:prstGeom prst="rect">
+            <a:avLst/>
+          </a:prstGeom>
+          <a:noFill/>
+          <a:ln/>
+        </p:spPr>
+        <p:txBody>
+          <a:bodyPr wrap="square" lIns="0" tIns="0" rIns="0" bIns="0" rtlCol="0" anchor="t">
+            <a:normAutofit/>
+          </a:bodyPr>
+          <a:lstStyle/>
+          <a:p>
+            <a:pPr marL="155956" indent="-155956">
+              <a:buSzPct val="100000"/>
+              <a:buChar char="•"/>
+            </a:pPr>
+            <a:r>
+              <a:rPr lang="en-US" sz="1400" dirty="0" err="1"/>
+              <a:t>Semua</a:t>
+            </a:r>
+            <a:r>
+              <a:rPr lang="en-US" sz="1400" dirty="0"/>
+              <a:t> </a:t>
+            </a:r>
+            <a:r>
+              <a:rPr lang="en-US" sz="1400" dirty="0" err="1"/>
+              <a:t>modul</a:t>
+            </a:r>
+            <a:r>
+              <a:rPr lang="en-US" sz="1400" dirty="0"/>
+              <a:t> </a:t>
+            </a:r>
+            <a:r>
+              <a:rPr lang="en-US" sz="1400" dirty="0" err="1"/>
+              <a:t>dalam</a:t>
+            </a:r>
+            <a:r>
+              <a:rPr lang="en-US" sz="1400" dirty="0"/>
+              <a:t> proposal </a:t>
+            </a:r>
+            <a:r>
+              <a:rPr lang="en-US" sz="1400" dirty="0" err="1"/>
+              <a:t>ini</a:t>
+            </a:r>
+            <a:endParaRPr lang="en-US" sz="1400" dirty="0"/>
+          </a:p>
+          <a:p>
+            <a:pPr marL="155956" indent="-155956">
+              <a:buSzPct val="100000"/>
+              <a:buChar char="•"/>
+            </a:pPr>
+            <a:r>
+              <a:rPr lang="en-US" sz="1400" dirty="0"/>
+              <a:t>Hosting, domain &amp; SSL </a:t>
+            </a:r>
+            <a:r>
+              <a:rPr lang="en-US" sz="1400" dirty="0" err="1"/>
+              <a:t>tahun</a:t>
+            </a:r>
+            <a:r>
+              <a:rPr lang="en-US" sz="1400" dirty="0"/>
+              <a:t> </a:t>
+            </a:r>
+            <a:r>
+              <a:rPr lang="en-US" sz="1400" dirty="0" err="1"/>
+              <a:t>pertama</a:t>
+            </a:r>
+            <a:r>
+              <a:rPr lang="en-US" sz="1400" dirty="0"/>
+              <a:t> </a:t>
+            </a:r>
+          </a:p>
+          <a:p>
+            <a:pPr marL="155956" indent="-155956">
+              <a:buSzPct val="100000"/>
+              <a:buChar char="•"/>
+            </a:pPr>
+            <a:r>
+              <a:rPr lang="en-US" sz="1400" dirty="0"/>
+              <a:t>Maintenance web server &amp; backup database </a:t>
+            </a:r>
+            <a:r>
+              <a:rPr lang="en-US" sz="1400" dirty="0" err="1"/>
+              <a:t>mingguan</a:t>
+            </a:r>
+            <a:r>
+              <a:rPr lang="en-US" sz="1400" dirty="0"/>
+              <a:t> </a:t>
+            </a:r>
+            <a:r>
+              <a:rPr lang="en-US" sz="1400" dirty="0" err="1"/>
+              <a:t>tahun</a:t>
+            </a:r>
+            <a:r>
+              <a:rPr lang="en-US" sz="1400" dirty="0"/>
+              <a:t> </a:t>
+            </a:r>
+            <a:r>
+              <a:rPr lang="en-US" sz="1400" dirty="0" err="1"/>
+              <a:t>pertama</a:t>
+            </a:r>
+            <a:endParaRPr lang="en-US" sz="1400" dirty="0"/>
+          </a:p>
+          <a:p>
+            <a:pPr marL="155956" indent="-155956">
+              <a:buSzPct val="100000"/>
+              <a:buChar char="•"/>
+            </a:pPr>
+            <a:r>
+              <a:rPr lang="en-US" sz="1400" dirty="0" err="1"/>
+              <a:t>Migrasi</a:t>
+            </a:r>
+            <a:r>
+              <a:rPr lang="en-US" sz="1400" dirty="0"/>
+              <a:t> data </a:t>
+            </a:r>
+            <a:r>
+              <a:rPr lang="en-US" sz="1400" dirty="0" err="1"/>
+              <a:t>dari</a:t>
+            </a:r>
+            <a:r>
+              <a:rPr lang="en-US" sz="1400" dirty="0"/>
+              <a:t> Excel / </a:t>
+            </a:r>
+            <a:r>
+              <a:rPr lang="en-US" sz="1400" dirty="0" err="1"/>
+              <a:t>sistem</a:t>
+            </a:r>
+            <a:r>
+              <a:rPr lang="en-US" sz="1400" dirty="0"/>
+              <a:t> lama </a:t>
+            </a:r>
+          </a:p>
+          <a:p>
+            <a:pPr marL="155956" indent="-155956">
+              <a:buSzPct val="100000"/>
+              <a:buChar char="•"/>
+            </a:pPr>
+            <a:r>
+              <a:rPr lang="en-US" sz="1400" dirty="0" err="1"/>
+              <a:t>Pelatihan</a:t>
+            </a:r>
+            <a:r>
+              <a:rPr lang="en-US" sz="1400" dirty="0"/>
+              <a:t> per </a:t>
+            </a:r>
+            <a:r>
+              <a:rPr lang="en-US" sz="1400" dirty="0" err="1"/>
+              <a:t>peran</a:t>
+            </a:r>
+            <a:r>
+              <a:rPr lang="en-US" sz="1400" dirty="0"/>
+              <a:t> &amp; </a:t>
+            </a:r>
+            <a:r>
+              <a:rPr lang="en-US" sz="1400" dirty="0" err="1"/>
+              <a:t>panduan</a:t>
+            </a:r>
+            <a:r>
+              <a:rPr lang="en-US" sz="1400" dirty="0"/>
+              <a:t> </a:t>
+            </a:r>
+            <a:r>
+              <a:rPr lang="en-US" sz="1400" dirty="0" err="1"/>
+              <a:t>pengguna</a:t>
+            </a:r>
+            <a:r>
+              <a:rPr lang="en-US" sz="1400" dirty="0"/>
+              <a:t> </a:t>
+            </a:r>
+          </a:p>
+          <a:p>
+            <a:pPr marL="155956" indent="-155956">
+              <a:buSzPct val="100000"/>
+              <a:buChar char="•"/>
+            </a:pPr>
+            <a:r>
+              <a:rPr lang="en-US" sz="1400" dirty="0"/>
+              <a:t>Testing, go-live &amp; maintenance 4 </a:t>
+            </a:r>
+            <a:r>
+              <a:rPr lang="en-US" sz="1400" dirty="0" err="1"/>
+              <a:t>bulan</a:t>
+            </a:r>
+            <a:r>
+              <a:rPr lang="en-US" sz="1400" dirty="0"/>
+              <a:t> </a:t>
+            </a:r>
+          </a:p>
+          <a:p>
+            <a:pPr marL="155956" indent="-155956">
+              <a:buSzPct val="100000"/>
+              <a:buChar char="•"/>
+            </a:pPr>
+            <a:r>
+              <a:rPr lang="en-US" sz="1400" dirty="0" err="1"/>
+              <a:t>Perbaikan</a:t>
+            </a:r>
+            <a:r>
+              <a:rPr lang="en-US" sz="1400" dirty="0"/>
+              <a:t> bug </a:t>
+            </a:r>
+            <a:r>
+              <a:rPr lang="en-US" sz="1400" dirty="0" err="1"/>
+              <a:t>tanpa</a:t>
+            </a:r>
+            <a:r>
+              <a:rPr lang="en-US" sz="1400" dirty="0"/>
+              <a:t> </a:t>
+            </a:r>
+            <a:r>
+              <a:rPr lang="en-US" sz="1400" dirty="0" err="1"/>
+              <a:t>biaya</a:t>
+            </a:r>
+            <a:r>
+              <a:rPr lang="en-US" sz="1400" dirty="0"/>
+              <a:t> </a:t>
+            </a:r>
+            <a:r>
+              <a:rPr lang="en-US" sz="1400" dirty="0" err="1"/>
+              <a:t>selama</a:t>
+            </a:r>
+            <a:r>
+              <a:rPr lang="en-US" sz="1400" dirty="0"/>
+              <a:t> masa maintenance</a:t>
+            </a:r>
+            <a:endParaRPr lang="en-US" sz="1300" dirty="0"/>
           </a:p>
         </p:txBody>
       </p:sp>
@@ -8913,61 +8986,6 @@
       </p:sp>
       <p:sp>
         <p:nvSpPr>
-          <p:cNvPr id="19" name="Text 14"/>
-          <p:cNvSpPr/>
-          <p:nvPr/>
-        </p:nvSpPr>
-        <p:spPr>
-          <a:xfrm>
-            <a:off x="812800" y="4469166"/>
-            <a:ext cx="10883392" cy="274285"/>
-          </a:xfrm>
-          <a:prstGeom prst="rect">
-            <a:avLst/>
-          </a:prstGeom>
-          <a:noFill/>
-          <a:ln/>
-        </p:spPr>
-        <p:txBody>
-          <a:bodyPr wrap="square" lIns="0" tIns="0" rIns="0" bIns="0" rtlCol="0" anchor="t">
-            <a:normAutofit/>
-          </a:bodyPr>
-          <a:lstStyle/>
-          <a:p>
-            <a:pPr marL="0" indent="0" algn="l">
-              <a:lnSpc>
-                <a:spcPts val="1960"/>
-              </a:lnSpc>
-              <a:buNone/>
-            </a:pPr>
-            <a:r>
-              <a:rPr lang="en-US" sz="1400" b="1">
-                <a:solidFill>
-                  <a:srgbClr val="4A5670"/>
-                </a:solidFill>
-                <a:latin typeface="Inter" pitchFamily="34" charset="0"/>
-                <a:ea typeface="Inter" pitchFamily="34" charset="-122"/>
-                <a:cs typeface="Inter" pitchFamily="34" charset="-120"/>
-              </a:rPr>
-              <a:t>Total biaya rutin tahun ke-2 dst. ± Rp8,5 jt / tahun</a:t>
-            </a:r>
-            <a:r>
-              <a:rPr lang="en-US" sz="1400">
-                <a:solidFill>
-                  <a:srgbClr val="4A5670"/>
-                </a:solidFill>
-                <a:latin typeface="Inter" pitchFamily="34" charset="0"/>
-                <a:ea typeface="Inter" pitchFamily="34" charset="-122"/>
-                <a:cs typeface="Inter" pitchFamily="34" charset="-120"/>
-              </a:rPr>
-              <a:t> (± Rp710 ribu / bulan).</a:t>
-            </a:r>
-            <a:endParaRPr lang="en-US" sz="1400" dirty="0"/>
-          </a:p>
-        </p:txBody>
-      </p:sp>
-      <p:sp>
-        <p:nvSpPr>
           <p:cNvPr id="20" name="Text 15"/>
           <p:cNvSpPr/>
           <p:nvPr/>
@@ -9156,7 +9174,7 @@
               <a:buNone/>
             </a:pPr>
             <a:r>
-              <a:rPr lang="it-IT" sz="3600" b="1" i="0">
+              <a:rPr lang="it-IT" sz="3600" b="1" i="0" dirty="0">
                 <a:solidFill>
                   <a:srgbClr val="F5F7FB"/>
                 </a:solidFill>
@@ -9438,7 +9456,7 @@
               <a:buNone/>
             </a:pPr>
             <a:r>
-              <a:rPr lang="en-US" sz="1400" b="1">
+              <a:rPr lang="en-US" sz="1400" b="1" dirty="0">
                 <a:solidFill>
                   <a:srgbClr val="16233F"/>
                 </a:solidFill>
@@ -9458,7 +9476,7 @@
               <a:buNone/>
             </a:pPr>
             <a:r>
-              <a:rPr lang="en-US" sz="1400">
+              <a:rPr lang="en-US" sz="1400" dirty="0">
                 <a:solidFill>
                   <a:srgbClr val="16233F"/>
                 </a:solidFill>
@@ -9486,7 +9504,7 @@
                 <a:ea typeface="Inter" pitchFamily="34" charset="-122"/>
                 <a:cs typeface="Inter" pitchFamily="34" charset="-120"/>
               </a:rPr>
-              <a:t>[No. HP / WhatsApp]</a:t>
+              <a:t>081281480122</a:t>
             </a:r>
             <a:endParaRPr lang="en-US" sz="1400" dirty="0"/>
           </a:p>
@@ -9506,7 +9524,7 @@
                 <a:ea typeface="Inter" pitchFamily="34" charset="-122"/>
                 <a:cs typeface="Inter" pitchFamily="34" charset="-120"/>
               </a:rPr>
-              <a:t>[Email]</a:t>
+              <a:t>erzie.aldrian02@gmail.com</a:t>
             </a:r>
             <a:endParaRPr lang="en-US" sz="1400" dirty="0"/>
           </a:p>
@@ -12331,7 +12349,7 @@
         </p:spPr>
         <p:txBody>
           <a:bodyPr wrap="square" lIns="0" tIns="0" rIns="0" bIns="0" rtlCol="0" anchor="t">
-            <a:normAutofit/>
+            <a:normAutofit fontScale="85000" lnSpcReduction="10000"/>
           </a:bodyPr>
           <a:lstStyle/>
           <a:p>
@@ -13354,7 +13372,7 @@
         </p:spPr>
         <p:txBody>
           <a:bodyPr wrap="square" lIns="0" tIns="0" rIns="0" bIns="0" rtlCol="0" anchor="t">
-            <a:normAutofit/>
+            <a:normAutofit fontScale="77500" lnSpcReduction="20000"/>
           </a:bodyPr>
           <a:lstStyle/>
           <a:p>
@@ -17026,11 +17044,10 @@
           </a:bodyPr>
           <a:lstStyle/>
           <a:p>
-            <a:pPr marL="0" indent="0" algn="l">
+            <a:pPr>
               <a:lnSpc>
                 <a:spcPts val="1960"/>
               </a:lnSpc>
-              <a:buNone/>
             </a:pPr>
             <a:r>
               <a:rPr lang="en-US" sz="1400" dirty="0">
@@ -17044,15 +17061,17 @@
               <a:t>Coba langsung: </a:t>
             </a:r>
             <a:r>
-              <a:rPr lang="en-US" sz="1400" b="1" dirty="0">
-                <a:solidFill>
-                  <a:srgbClr val="F5F7FB"/>
+              <a:rPr lang="en-US" sz="1400" dirty="0">
+                <a:solidFill>
+                  <a:schemeClr val="accent2">
+                    <a:lumMod val="75000"/>
+                  </a:schemeClr>
                 </a:solidFill>
                 <a:latin typeface="Inter" pitchFamily="34" charset="0"/>
                 <a:ea typeface="Inter" pitchFamily="34" charset="-122"/>
                 <a:cs typeface="Inter" pitchFamily="34" charset="-120"/>
               </a:rPr>
-              <a:t>[link prototype]</a:t>
+              <a:t>https://tkn-project-management.netlify.app/</a:t>
             </a:r>
             <a:r>
               <a:rPr lang="en-US" sz="1400" dirty="0">
@@ -17063,7 +17082,7 @@
                 <a:ea typeface="Inter" pitchFamily="34" charset="-122"/>
                 <a:cs typeface="Inter" pitchFamily="34" charset="-120"/>
               </a:rPr>
-              <a:t> · login demo per peran tersedia</a:t>
+              <a:t>· login demo per peran tersedia</a:t>
             </a:r>
             <a:endParaRPr lang="en-US" sz="1400" dirty="0"/>
           </a:p>
@@ -17410,7 +17429,7 @@
         </p:nvGraphicFramePr>
         <p:xfrm>
           <a:off x="5396089" y="824089"/>
-          <a:ext cx="5983111" cy="2691695"/>
+          <a:ext cx="5983111" cy="2691696"/>
         </p:xfrm>
         <a:graphic>
           <a:graphicData uri="http://schemas.openxmlformats.org/drawingml/2006/table">

</xml_diff>